<commit_message>
docs(report): expand comprehensive capstone report to 23 pages with Dr. MANIKANDAN K as guide and all 10 visual modules
</commit_message>
<xml_diff>
--- a/Team_VisualAnalytics_SmartEnergy_PowerBI_v2.pptx
+++ b/Team_VisualAnalytics_SmartEnergy_PowerBI_v2.pptx
@@ -3572,7 +3572,7 @@
                 </a:solidFill>
                 <a:latin typeface="Segoe UI"/>
               </a:rPr>
-              <a:t>SUBMITTED TO / EVALUATOR:</a:t>
+              <a:t>SUBMITTED TO / FACULTY EVALUATOR &amp; GUIDE:</a:t>
             </a:r>
           </a:p>
           <a:p>
@@ -3591,7 +3591,7 @@
                 </a:solidFill>
                 <a:latin typeface="Segoe UI"/>
               </a:rPr>
-              <a:t>Dr. Mary Jennifer J  |  Assistant Professor (Senior), School of Social Sciences &amp; Languages (SSL) / Evaluator</a:t>
+              <a:t>Dr. MANIKANDAN K  |  Professor Grade 2, Department of Database Systems</a:t>
             </a:r>
           </a:p>
           <a:p>
@@ -3610,7 +3610,7 @@
                 </a:solidFill>
                 <a:latin typeface="Segoe UI"/>
               </a:rPr>
-              <a:t>School of Computer Science and Engineering (SCOPE), Vellore Institute of Technology, Vellore - 632014</a:t>
+              <a:t>School of Computer Science and Engineering (SCOPE), VIT Vellore (Cabin: SJT 411 A29 • Email: kmanikandan@vit.ac.in)</a:t>
             </a:r>
           </a:p>
         </p:txBody>

</xml_diff>